<commit_message>
Resolve theme outline references, correct fixture complex-script font and capture Android visuals
</commit_message>
<xml_diff>
--- a/app/src/test/resources/fixtures/drawing-fonts-white.pptx
+++ b/app/src/test/resources/fixtures/drawing-fonts-white.pptx
@@ -3271,6 +3271,7 @@
               <a:r>
                 <a:rPr sz="2400">
                   <a:latin typeface="Cairo"/>
+                  <a:cs typeface="Cairo"/>
                 </a:rPr>
                 <a:t>مرحبا</a:t>
               </a:r>
@@ -3353,6 +3354,36 @@
           </a:p>
         </p:txBody>
       </p:sp>
+      <p:cxnSp>
+        <p:nvCxnSpPr>
+          <p:cNvPr id="3" name="Connector 2"/>
+          <p:cNvCxnSpPr/>
+          <p:nvPr/>
+        </p:nvCxnSpPr>
+        <p:spPr>
+          <a:xfrm>
+            <a:off x="7315200" y="914400"/>
+            <a:ext cx="0" cy="2743200"/>
+          </a:xfrm>
+          <a:prstGeom prst="line">
+            <a:avLst/>
+          </a:prstGeom>
+        </p:spPr>
+        <p:style>
+          <a:lnRef idx="2">
+            <a:schemeClr val="accent1"/>
+          </a:lnRef>
+          <a:fillRef idx="0">
+            <a:schemeClr val="accent1"/>
+          </a:fillRef>
+          <a:effectRef idx="1">
+            <a:schemeClr val="accent1"/>
+          </a:effectRef>
+          <a:fontRef idx="minor">
+            <a:schemeClr val="tx1"/>
+          </a:fontRef>
+        </p:style>
+      </p:cxnSp>
     </p:spTree>
   </p:cSld>
   <p:clrMapOvr>

</xml_diff>